<commit_message>
Commit regenerated public deck output (FTE fix content, no other changes)
Co-Authored-By: Claude Sonnet 5 <noreply@anthropic.com>
</commit_message>
<xml_diff>
--- a/deck/Example Co. Strategy Deck.pptx
+++ b/deck/Example Co. Strategy Deck.pptx
@@ -5604,7 +5604,7 @@
               </a:defRPr>
             </a:pPr>
             <a:r>
-              <a:t>$6.25</a:t>
+              <a:t>$5.83</a:t>
             </a:r>
           </a:p>
           <a:p>
@@ -5670,7 +5670,7 @@
               </a:defRPr>
             </a:pPr>
             <a:r>
-              <a:t>$5.32</a:t>
+              <a:t>$4.96</a:t>
             </a:r>
           </a:p>
           <a:p>
@@ -5717,7 +5717,7 @@
               </a:defRPr>
             </a:pPr>
             <a:r>
-              <a:t>30 FTEs × $15K = $450K/yr ÷ 72,000 inquiries/yr.</a:t>
+              <a:t>28 FTEs × $15K = $420K/yr ÷ 72,000 inquiries/yr.</a:t>
             </a:r>
           </a:p>
           <a:p>
@@ -5747,7 +5747,7 @@
               </a:defRPr>
             </a:pPr>
             <a:r>
-              <a:t>Same 30 FTEs then absorb ~18% more volume; AI cost at that volume (real measured rate) stays trivial either way.</a:t>
+              <a:t>Same 28 FTEs then absorb ~18% more volume; AI cost at that volume (real measured rate) stays trivial either way.</a:t>
             </a:r>
           </a:p>
         </p:txBody>

</xml_diff>